<commit_message>
Kit 2 founder slots filled from owner stories
- Slide 8: Adam's french-polish story (AI claimed shellac unnecessary
  for a french polish; expertise caught what perfect writing hid)
- Slide 17: shared take on voice in parent/student communication
- Slide 19: Adam's real CNC table-leg prompt as the worked example
- Deck speaker notes updated to cue each passage

Co-Authored-By: Claude Opus 5 <noreply@anthropic.com>
Claude-Session: https://claude.ai/code/session_01UrWWr3vbRywthE5aNZWdnr
</commit_message>
<xml_diff>
--- a/kits/kit02/Kit02_PresentationDeck.pptx
+++ b/kits/kit02/Kit02_PresentationDeck.pptx
@@ -1235,7 +1235,7 @@
           <a:p>
             <a:r>
               <a:rPr lang="en-US" dirty="0"/>
-              <a:t>YOUR TAKE slot lands here; read the authors’ stated boundary from the script: what they refuse to let AI write, and why.</a:t>
+              <a:t>Read the authors’ shared take from the script: voice matters most in personal communication with parents and students; academic language has its place, but empathetic personal messages should be in the teacher’s own words.</a:t>
             </a:r>
             <a:endParaRPr lang="en-US" dirty="0"/>
           </a:p>
@@ -1411,7 +1411,7 @@
           <a:p>
             <a:r>
               <a:rPr lang="en-US" dirty="0"/>
-              <a:t>Circulate. Weak prompts usually lack context; nudge with "what would a substitute need to know to do this right?"</a:t>
+              <a:t>Circulate. Weak prompts usually lack context; nudge with "what would a substitute need to know to do this right?" Then read Adam’s real CNC table-leg prompt from the script as the worked example (three stacked roles, one task, SVG-for-CNC format).</a:t>
             </a:r>
             <a:endParaRPr lang="en-US" dirty="0"/>
           </a:p>
@@ -2995,7 +2995,7 @@
           <a:p>
             <a:r>
               <a:rPr lang="en-US" dirty="0"/>
-              <a:t>FOUNDER STORY slot lands here; read it from the script: a time a genuinely good prompt still produced something confidently wrong, and the review caught it.</a:t>
+              <a:t>Read Adam’s french-polish story from the script: a well-iterated prompt for guitar-finishing instructions confidently claimed shellac was not a necessary ingredient for a french polish (a finish that IS shellac). His expertise caught it; the writing looked perfect.</a:t>
             </a:r>
             <a:endParaRPr lang="en-US" dirty="0"/>
           </a:p>

</xml_diff>